<commit_message>
Day 12: PPT saved
</commit_message>
<xml_diff>
--- a/day12/Day12_Mini Capstone Project.pptx
+++ b/day12/Day12_Mini Capstone Project.pptx
@@ -5,15 +5,16 @@
     <p:sldMasterId id="2147483648" r:id="rId1"/>
   </p:sldMasterIdLst>
   <p:notesMasterIdLst>
-    <p:notesMasterId r:id="rId8"/>
+    <p:notesMasterId r:id="rId9"/>
   </p:notesMasterIdLst>
   <p:sldIdLst>
     <p:sldId id="256" r:id="rId2"/>
     <p:sldId id="280" r:id="rId3"/>
     <p:sldId id="281" r:id="rId4"/>
     <p:sldId id="282" r:id="rId5"/>
-    <p:sldId id="279" r:id="rId6"/>
-    <p:sldId id="278" r:id="rId7"/>
+    <p:sldId id="283" r:id="rId6"/>
+    <p:sldId id="279" r:id="rId7"/>
+    <p:sldId id="278" r:id="rId8"/>
   </p:sldIdLst>
   <p:sldSz cx="9144000" cy="5143500" type="screen16x9"/>
   <p:notesSz cx="5143500" cy="9144000"/>
@@ -658,6 +659,114 @@
         <p:cNvPr id="1" name="">
           <a:extLst>
             <a:ext uri="{FF2B5EF4-FFF2-40B4-BE49-F238E27FC236}">
+              <a16:creationId xmlns:a16="http://schemas.microsoft.com/office/drawing/2014/main" id="{9C8E3A9D-9A4B-8A50-2B6A-E00B454091B8}"/>
+            </a:ext>
+          </a:extLst>
+        </p:cNvPr>
+        <p:cNvGrpSpPr/>
+        <p:nvPr/>
+      </p:nvGrpSpPr>
+      <p:grpSpPr>
+        <a:xfrm>
+          <a:off x="0" y="0"/>
+          <a:ext cx="0" cy="0"/>
+          <a:chOff x="0" y="0"/>
+          <a:chExt cx="0" cy="0"/>
+        </a:xfrm>
+      </p:grpSpPr>
+      <p:sp>
+        <p:nvSpPr>
+          <p:cNvPr id="2" name="Slide Image Placeholder 1">
+            <a:extLst>
+              <a:ext uri="{FF2B5EF4-FFF2-40B4-BE49-F238E27FC236}">
+                <a16:creationId xmlns:a16="http://schemas.microsoft.com/office/drawing/2014/main" id="{B543CE70-66CB-19A0-3013-D50B1832FB6B}"/>
+              </a:ext>
+            </a:extLst>
+          </p:cNvPr>
+          <p:cNvSpPr>
+            <a:spLocks noGrp="1" noRot="1" noChangeAspect="1"/>
+          </p:cNvSpPr>
+          <p:nvPr>
+            <p:ph type="sldImg"/>
+          </p:nvPr>
+        </p:nvSpPr>
+        <p:spPr/>
+      </p:sp>
+      <p:sp>
+        <p:nvSpPr>
+          <p:cNvPr id="3" name="Notes Placeholder 2">
+            <a:extLst>
+              <a:ext uri="{FF2B5EF4-FFF2-40B4-BE49-F238E27FC236}">
+                <a16:creationId xmlns:a16="http://schemas.microsoft.com/office/drawing/2014/main" id="{189B5347-5296-4F5B-0C72-D2D215956D0C}"/>
+              </a:ext>
+            </a:extLst>
+          </p:cNvPr>
+          <p:cNvSpPr>
+            <a:spLocks noGrp="1"/>
+          </p:cNvSpPr>
+          <p:nvPr>
+            <p:ph type="body" idx="1"/>
+          </p:nvPr>
+        </p:nvSpPr>
+        <p:spPr/>
+        <p:txBody>
+          <a:bodyPr/>
+          <a:lstStyle/>
+          <a:p>
+            <a:endParaRPr lang="en-US" dirty="0"/>
+          </a:p>
+        </p:txBody>
+      </p:sp>
+      <p:sp>
+        <p:nvSpPr>
+          <p:cNvPr id="4" name="Slide Number Placeholder 3">
+            <a:extLst>
+              <a:ext uri="{FF2B5EF4-FFF2-40B4-BE49-F238E27FC236}">
+                <a16:creationId xmlns:a16="http://schemas.microsoft.com/office/drawing/2014/main" id="{420A4064-DBC1-C0A5-8A30-6974BE7AFEBA}"/>
+              </a:ext>
+            </a:extLst>
+          </p:cNvPr>
+          <p:cNvSpPr>
+            <a:spLocks noGrp="1"/>
+          </p:cNvSpPr>
+          <p:nvPr>
+            <p:ph type="sldNum" sz="quarter" idx="10"/>
+          </p:nvPr>
+        </p:nvSpPr>
+        <p:spPr/>
+        <p:txBody>
+          <a:bodyPr/>
+          <a:lstStyle/>
+          <a:p>
+            <a:fld id="{F7021451-1387-4CA6-816F-3879F97B5CBC}" type="slidenum">
+              <a:rPr lang="en-US"/>
+              <a:t>5</a:t>
+            </a:fld>
+            <a:endParaRPr lang="en-US"/>
+          </a:p>
+        </p:txBody>
+      </p:sp>
+    </p:spTree>
+    <p:extLst>
+      <p:ext uri="{BB962C8B-B14F-4D97-AF65-F5344CB8AC3E}">
+        <p14:creationId xmlns:p14="http://schemas.microsoft.com/office/powerpoint/2010/main" val="3635870157"/>
+      </p:ext>
+    </p:extLst>
+  </p:cSld>
+  <p:clrMapOvr>
+    <a:masterClrMapping/>
+  </p:clrMapOvr>
+</p:notes>
+</file>
+
+<file path=ppt/notesSlides/notesSlide6.xml><?xml version="1.0" encoding="utf-8"?>
+<p:notes xmlns:a="http://schemas.openxmlformats.org/drawingml/2006/main" xmlns:r="http://schemas.openxmlformats.org/officeDocument/2006/relationships" xmlns:p="http://schemas.openxmlformats.org/presentationml/2006/main">
+  <p:cSld>
+    <p:spTree>
+      <p:nvGrpSpPr>
+        <p:cNvPr id="1" name="">
+          <a:extLst>
+            <a:ext uri="{FF2B5EF4-FFF2-40B4-BE49-F238E27FC236}">
               <a16:creationId xmlns:a16="http://schemas.microsoft.com/office/drawing/2014/main" id="{0D284F55-A01B-24D3-EC46-9CEA396C1718}"/>
             </a:ext>
           </a:extLst>
@@ -739,7 +848,7 @@
           <a:p>
             <a:fld id="{F7021451-1387-4CA6-816F-3879F97B5CBC}" type="slidenum">
               <a:rPr lang="en-US"/>
-              <a:t>5</a:t>
+              <a:t>6</a:t>
             </a:fld>
             <a:endParaRPr lang="en-US"/>
           </a:p>
@@ -758,7 +867,7 @@
 </p:notes>
 </file>
 
-<file path=ppt/notesSlides/notesSlide6.xml><?xml version="1.0" encoding="utf-8"?>
+<file path=ppt/notesSlides/notesSlide7.xml><?xml version="1.0" encoding="utf-8"?>
 <p:notes xmlns:a="http://schemas.openxmlformats.org/drawingml/2006/main" xmlns:r="http://schemas.openxmlformats.org/officeDocument/2006/relationships" xmlns:p="http://schemas.openxmlformats.org/presentationml/2006/main">
   <p:cSld>
     <p:spTree>
@@ -823,7 +932,7 @@
           <a:p>
             <a:fld id="{F7021451-1387-4CA6-816F-3879F97B5CBC}" type="slidenum">
               <a:rPr lang="en-US"/>
-              <a:t>6</a:t>
+              <a:t>7</a:t>
             </a:fld>
             <a:endParaRPr lang="en-US"/>
           </a:p>
@@ -2414,6 +2523,483 @@
         <p:cNvPr id="1" name="">
           <a:extLst>
             <a:ext uri="{FF2B5EF4-FFF2-40B4-BE49-F238E27FC236}">
+              <a16:creationId xmlns:a16="http://schemas.microsoft.com/office/drawing/2014/main" id="{AC3E06FD-2373-CABC-E72E-EACAEB65CF74}"/>
+            </a:ext>
+          </a:extLst>
+        </p:cNvPr>
+        <p:cNvGrpSpPr/>
+        <p:nvPr/>
+      </p:nvGrpSpPr>
+      <p:grpSpPr>
+        <a:xfrm>
+          <a:off x="0" y="0"/>
+          <a:ext cx="0" cy="0"/>
+          <a:chOff x="0" y="0"/>
+          <a:chExt cx="0" cy="0"/>
+        </a:xfrm>
+      </p:grpSpPr>
+      <p:sp>
+        <p:nvSpPr>
+          <p:cNvPr id="2" name="Shape 0">
+            <a:extLst>
+              <a:ext uri="{FF2B5EF4-FFF2-40B4-BE49-F238E27FC236}">
+                <a16:creationId xmlns:a16="http://schemas.microsoft.com/office/drawing/2014/main" id="{AD93DD0D-AAFF-0A45-63B1-3FB5C10E9BAF}"/>
+              </a:ext>
+            </a:extLst>
+          </p:cNvPr>
+          <p:cNvSpPr/>
+          <p:nvPr/>
+        </p:nvSpPr>
+        <p:spPr>
+          <a:xfrm>
+            <a:off x="0" y="914400"/>
+            <a:ext cx="164592" cy="3291840"/>
+          </a:xfrm>
+          <a:prstGeom prst="rect">
+            <a:avLst/>
+          </a:prstGeom>
+          <a:solidFill>
+            <a:srgbClr val="00E5A0"/>
+          </a:solidFill>
+          <a:ln w="12700">
+            <a:solidFill>
+              <a:srgbClr val="00E5A0"/>
+            </a:solidFill>
+            <a:prstDash val="solid"/>
+          </a:ln>
+        </p:spPr>
+      </p:sp>
+      <p:sp>
+        <p:nvSpPr>
+          <p:cNvPr id="5" name="Text 3">
+            <a:extLst>
+              <a:ext uri="{FF2B5EF4-FFF2-40B4-BE49-F238E27FC236}">
+                <a16:creationId xmlns:a16="http://schemas.microsoft.com/office/drawing/2014/main" id="{F682E109-8410-4CB3-F2E7-FF869A2D1E8F}"/>
+              </a:ext>
+            </a:extLst>
+          </p:cNvPr>
+          <p:cNvSpPr/>
+          <p:nvPr/>
+        </p:nvSpPr>
+        <p:spPr>
+          <a:xfrm>
+            <a:off x="304800" y="1469814"/>
+            <a:ext cx="8906933" cy="2011680"/>
+          </a:xfrm>
+          <a:prstGeom prst="rect">
+            <a:avLst/>
+          </a:prstGeom>
+          <a:noFill/>
+          <a:ln/>
+        </p:spPr>
+        <p:txBody>
+          <a:bodyPr wrap="square" lIns="0" tIns="0" rIns="0" bIns="0" rtlCol="0" anchor="ctr"/>
+          <a:lstStyle/>
+          <a:p>
+            <a:endParaRPr lang="en-US" sz="2000" dirty="0">
+              <a:solidFill>
+                <a:schemeClr val="bg1"/>
+              </a:solidFill>
+              <a:latin typeface="Aptos Narrow" pitchFamily="34" charset="0"/>
+            </a:endParaRPr>
+          </a:p>
+          <a:p>
+            <a:r>
+              <a:rPr lang="en-US" sz="2000" dirty="0">
+                <a:solidFill>
+                  <a:schemeClr val="bg1"/>
+                </a:solidFill>
+                <a:latin typeface="Aptos Narrow" pitchFamily="34" charset="0"/>
+              </a:rPr>
+              <a:t>Create setup_kb.py that:</a:t>
+            </a:r>
+          </a:p>
+          <a:p>
+            <a:r>
+              <a:rPr lang="en-US" sz="2000" dirty="0">
+                <a:solidFill>
+                  <a:schemeClr val="bg1"/>
+                </a:solidFill>
+                <a:latin typeface="Aptos Narrow" pitchFamily="34" charset="0"/>
+              </a:rPr>
+              <a:t>1. Reads all .md files from lab/</a:t>
+            </a:r>
+            <a:r>
+              <a:rPr lang="en-US" sz="2000" dirty="0" err="1">
+                <a:solidFill>
+                  <a:schemeClr val="bg1"/>
+                </a:solidFill>
+                <a:latin typeface="Aptos Narrow" pitchFamily="34" charset="0"/>
+              </a:rPr>
+              <a:t>knowledge_base</a:t>
+            </a:r>
+            <a:r>
+              <a:rPr lang="en-US" sz="2000" dirty="0">
+                <a:solidFill>
+                  <a:schemeClr val="bg1"/>
+                </a:solidFill>
+                <a:latin typeface="Aptos Narrow" pitchFamily="34" charset="0"/>
+              </a:rPr>
+              <a:t>/</a:t>
+            </a:r>
+          </a:p>
+          <a:p>
+            <a:r>
+              <a:rPr lang="en-US" sz="2000" dirty="0">
+                <a:solidFill>
+                  <a:schemeClr val="bg1"/>
+                </a:solidFill>
+                <a:latin typeface="Aptos Narrow" pitchFamily="34" charset="0"/>
+              </a:rPr>
+              <a:t>2. Calls Bedrock Titan Embeddings (amazon.titan-embed-text-v2:0) to embed each document</a:t>
+            </a:r>
+          </a:p>
+          <a:p>
+            <a:r>
+              <a:rPr lang="en-US" sz="2000" dirty="0">
+                <a:solidFill>
+                  <a:schemeClr val="bg1"/>
+                </a:solidFill>
+                <a:latin typeface="Aptos Narrow" pitchFamily="34" charset="0"/>
+              </a:rPr>
+              <a:t>3. Saves the index as </a:t>
+            </a:r>
+            <a:r>
+              <a:rPr lang="en-US" sz="2000" dirty="0" err="1">
+                <a:solidFill>
+                  <a:schemeClr val="bg1"/>
+                </a:solidFill>
+                <a:latin typeface="Aptos Narrow" pitchFamily="34" charset="0"/>
+              </a:rPr>
+              <a:t>knowledge_base</a:t>
+            </a:r>
+            <a:r>
+              <a:rPr lang="en-US" sz="2000" dirty="0">
+                <a:solidFill>
+                  <a:schemeClr val="bg1"/>
+                </a:solidFill>
+                <a:latin typeface="Aptos Narrow" pitchFamily="34" charset="0"/>
+              </a:rPr>
+              <a:t>/</a:t>
+            </a:r>
+            <a:r>
+              <a:rPr lang="en-US" sz="2000" dirty="0" err="1">
+                <a:solidFill>
+                  <a:schemeClr val="bg1"/>
+                </a:solidFill>
+                <a:latin typeface="Aptos Narrow" pitchFamily="34" charset="0"/>
+              </a:rPr>
+              <a:t>index.json</a:t>
+            </a:r>
+            <a:r>
+              <a:rPr lang="en-US" sz="2000" dirty="0">
+                <a:solidFill>
+                  <a:schemeClr val="bg1"/>
+                </a:solidFill>
+                <a:latin typeface="Aptos Narrow" pitchFamily="34" charset="0"/>
+              </a:rPr>
+              <a:t> in your S3 bucket</a:t>
+            </a:r>
+          </a:p>
+          <a:p>
+            <a:r>
+              <a:rPr lang="en-US" sz="2000" dirty="0">
+                <a:solidFill>
+                  <a:schemeClr val="bg1"/>
+                </a:solidFill>
+                <a:latin typeface="Aptos Narrow" pitchFamily="34" charset="0"/>
+              </a:rPr>
+              <a:t> </a:t>
+            </a:r>
+          </a:p>
+          <a:p>
+            <a:r>
+              <a:rPr lang="en-US" sz="2000" dirty="0">
+                <a:solidFill>
+                  <a:schemeClr val="bg1"/>
+                </a:solidFill>
+                <a:latin typeface="Aptos Narrow" pitchFamily="34" charset="0"/>
+              </a:rPr>
+              <a:t> Then update test_knowledge_base.py to:</a:t>
+            </a:r>
+          </a:p>
+          <a:p>
+            <a:r>
+              <a:rPr lang="en-US" sz="2000" dirty="0">
+                <a:solidFill>
+                  <a:schemeClr val="bg1"/>
+                </a:solidFill>
+                <a:latin typeface="Aptos Narrow" pitchFamily="34" charset="0"/>
+              </a:rPr>
+              <a:t> 1. Load the index from S3</a:t>
+            </a:r>
+          </a:p>
+          <a:p>
+            <a:r>
+              <a:rPr lang="en-US" sz="2000" dirty="0">
+                <a:solidFill>
+                  <a:schemeClr val="bg1"/>
+                </a:solidFill>
+                <a:latin typeface="Aptos Narrow" pitchFamily="34" charset="0"/>
+              </a:rPr>
+              <a:t> 2. Embed the query using the same model</a:t>
+            </a:r>
+          </a:p>
+          <a:p>
+            <a:r>
+              <a:rPr lang="en-US" sz="2000" dirty="0">
+                <a:solidFill>
+                  <a:schemeClr val="bg1"/>
+                </a:solidFill>
+                <a:latin typeface="Aptos Narrow" pitchFamily="34" charset="0"/>
+              </a:rPr>
+              <a:t> 3. Do cosine similarity (</a:t>
+            </a:r>
+            <a:r>
+              <a:rPr lang="en-US" sz="2000" dirty="0" err="1">
+                <a:solidFill>
+                  <a:schemeClr val="bg1"/>
+                </a:solidFill>
+                <a:latin typeface="Aptos Narrow" pitchFamily="34" charset="0"/>
+              </a:rPr>
+              <a:t>numpy</a:t>
+            </a:r>
+            <a:r>
+              <a:rPr lang="en-US" sz="2000" dirty="0">
+                <a:solidFill>
+                  <a:schemeClr val="bg1"/>
+                </a:solidFill>
+                <a:latin typeface="Aptos Narrow" pitchFamily="34" charset="0"/>
+              </a:rPr>
+              <a:t>)</a:t>
+            </a:r>
+          </a:p>
+          <a:p>
+            <a:r>
+              <a:rPr lang="en-US" sz="2000" dirty="0">
+                <a:solidFill>
+                  <a:schemeClr val="bg1"/>
+                </a:solidFill>
+                <a:latin typeface="Aptos Narrow" pitchFamily="34" charset="0"/>
+              </a:rPr>
+              <a:t> 4. Return top 3 results</a:t>
+            </a:r>
+            <a:endParaRPr lang="en-US" dirty="0">
+              <a:solidFill>
+                <a:srgbClr val="FFC000"/>
+              </a:solidFill>
+            </a:endParaRPr>
+          </a:p>
+        </p:txBody>
+      </p:sp>
+      <p:sp>
+        <p:nvSpPr>
+          <p:cNvPr id="7" name="Text 1">
+            <a:extLst>
+              <a:ext uri="{FF2B5EF4-FFF2-40B4-BE49-F238E27FC236}">
+                <a16:creationId xmlns:a16="http://schemas.microsoft.com/office/drawing/2014/main" id="{52ACF6B3-19E4-24DE-5360-F66BB3C867EC}"/>
+              </a:ext>
+            </a:extLst>
+          </p:cNvPr>
+          <p:cNvSpPr/>
+          <p:nvPr/>
+        </p:nvSpPr>
+        <p:spPr>
+          <a:xfrm>
+            <a:off x="365760" y="-33867"/>
+            <a:ext cx="8412480" cy="1070187"/>
+          </a:xfrm>
+          <a:prstGeom prst="rect">
+            <a:avLst/>
+          </a:prstGeom>
+          <a:noFill/>
+          <a:ln/>
+        </p:spPr>
+        <p:txBody>
+          <a:bodyPr wrap="square" lIns="0" tIns="0" rIns="0" bIns="0" rtlCol="0" anchor="ctr"/>
+          <a:lstStyle/>
+          <a:p>
+            <a:r>
+              <a:rPr lang="en-US" sz="4200" b="1" dirty="0">
+                <a:solidFill>
+                  <a:srgbClr val="FFFFFF"/>
+                </a:solidFill>
+                <a:latin typeface="Aptos Narrow" pitchFamily="34" charset="0"/>
+              </a:rPr>
+              <a:t>Knowledge base creation - approach</a:t>
+            </a:r>
+            <a:endParaRPr lang="en-US" sz="4200" dirty="0"/>
+          </a:p>
+        </p:txBody>
+      </p:sp>
+      <p:sp>
+        <p:nvSpPr>
+          <p:cNvPr id="3" name="TextBox 2">
+            <a:extLst>
+              <a:ext uri="{FF2B5EF4-FFF2-40B4-BE49-F238E27FC236}">
+                <a16:creationId xmlns:a16="http://schemas.microsoft.com/office/drawing/2014/main" id="{DE60D921-DB1F-0AB3-9766-5AF3DD8C9B31}"/>
+              </a:ext>
+            </a:extLst>
+          </p:cNvPr>
+          <p:cNvSpPr txBox="1"/>
+          <p:nvPr/>
+        </p:nvSpPr>
+        <p:spPr>
+          <a:xfrm>
+            <a:off x="1727199" y="4538133"/>
+            <a:ext cx="6177279" cy="369332"/>
+          </a:xfrm>
+          <a:prstGeom prst="rect">
+            <a:avLst/>
+          </a:prstGeom>
+          <a:noFill/>
+        </p:spPr>
+        <p:txBody>
+          <a:bodyPr wrap="square" rtlCol="0">
+            <a:spAutoFit/>
+          </a:bodyPr>
+          <a:lstStyle/>
+          <a:p>
+            <a:r>
+              <a:rPr lang="en-US" b="1" dirty="0">
+                <a:solidFill>
+                  <a:srgbClr val="FF0000"/>
+                </a:solidFill>
+              </a:rPr>
+              <a:t>Attention : Avoid using AWS Open Search SERVERLESS</a:t>
+            </a:r>
+            <a:endParaRPr lang="en-IN" b="1" dirty="0">
+              <a:solidFill>
+                <a:srgbClr val="FF0000"/>
+              </a:solidFill>
+            </a:endParaRPr>
+          </a:p>
+        </p:txBody>
+      </p:sp>
+      <p:sp>
+        <p:nvSpPr>
+          <p:cNvPr id="6" name="TextBox 5">
+            <a:extLst>
+              <a:ext uri="{FF2B5EF4-FFF2-40B4-BE49-F238E27FC236}">
+                <a16:creationId xmlns:a16="http://schemas.microsoft.com/office/drawing/2014/main" id="{9BA407F4-5501-2CF2-1ED4-78FFCA30860F}"/>
+              </a:ext>
+            </a:extLst>
+          </p:cNvPr>
+          <p:cNvSpPr txBox="1"/>
+          <p:nvPr/>
+        </p:nvSpPr>
+        <p:spPr>
+          <a:xfrm>
+            <a:off x="5542280" y="3116072"/>
+            <a:ext cx="3432387" cy="1169551"/>
+          </a:xfrm>
+          <a:prstGeom prst="rect">
+            <a:avLst/>
+          </a:prstGeom>
+          <a:noFill/>
+        </p:spPr>
+        <p:txBody>
+          <a:bodyPr wrap="square">
+            <a:spAutoFit/>
+          </a:bodyPr>
+          <a:lstStyle/>
+          <a:p>
+            <a:r>
+              <a:rPr lang="en-IN" sz="1400" b="1" dirty="0">
+                <a:solidFill>
+                  <a:srgbClr val="FFC000"/>
+                </a:solidFill>
+              </a:rPr>
+              <a:t>Refer to lab/</a:t>
+            </a:r>
+            <a:r>
+              <a:rPr lang="en-IN" sz="1400" b="1" dirty="0" err="1">
+                <a:solidFill>
+                  <a:srgbClr val="FFC000"/>
+                </a:solidFill>
+              </a:rPr>
+              <a:t>knowledge_base</a:t>
+            </a:r>
+            <a:r>
+              <a:rPr lang="en-IN" sz="1400" b="1" dirty="0">
+                <a:solidFill>
+                  <a:srgbClr val="FFC000"/>
+                </a:solidFill>
+              </a:rPr>
+              <a:t>/</a:t>
+            </a:r>
+          </a:p>
+          <a:p>
+            <a:r>
+              <a:rPr lang="en-IN" sz="1400" dirty="0">
+                <a:solidFill>
+                  <a:srgbClr val="FFC000"/>
+                </a:solidFill>
+              </a:rPr>
+              <a:t>    sla_contracts/quickmart_sla.md</a:t>
+            </a:r>
+          </a:p>
+          <a:p>
+            <a:r>
+              <a:rPr lang="en-IN" sz="1400" dirty="0">
+                <a:solidFill>
+                  <a:srgbClr val="FFC000"/>
+                </a:solidFill>
+              </a:rPr>
+              <a:t>    sla_contracts/fuelplus_sla.md</a:t>
+            </a:r>
+          </a:p>
+          <a:p>
+            <a:r>
+              <a:rPr lang="en-IN" sz="1400" dirty="0">
+                <a:solidFill>
+                  <a:srgbClr val="FFC000"/>
+                </a:solidFill>
+              </a:rPr>
+              <a:t>    runbooks/kinesis_replay_runbook.md</a:t>
+            </a:r>
+          </a:p>
+          <a:p>
+            <a:r>
+              <a:rPr lang="en-IN" sz="1400" dirty="0">
+                <a:solidFill>
+                  <a:srgbClr val="FFC000"/>
+                </a:solidFill>
+              </a:rPr>
+              <a:t>    data_contracts/sigma_transactions_v1.md</a:t>
+            </a:r>
+          </a:p>
+        </p:txBody>
+      </p:sp>
+    </p:spTree>
+    <p:extLst>
+      <p:ext uri="{BB962C8B-B14F-4D97-AF65-F5344CB8AC3E}">
+        <p14:creationId xmlns:p14="http://schemas.microsoft.com/office/powerpoint/2010/main" val="1778648976"/>
+      </p:ext>
+    </p:extLst>
+  </p:cSld>
+  <p:clrMapOvr>
+    <a:masterClrMapping/>
+  </p:clrMapOvr>
+</p:sld>
+</file>
+
+<file path=ppt/slides/slide6.xml><?xml version="1.0" encoding="utf-8"?>
+<p:sld xmlns:a="http://schemas.openxmlformats.org/drawingml/2006/main" xmlns:r="http://schemas.openxmlformats.org/officeDocument/2006/relationships" xmlns:p="http://schemas.openxmlformats.org/presentationml/2006/main">
+  <p:cSld>
+    <p:bg>
+      <p:bgPr>
+        <a:solidFill>
+          <a:srgbClr val="0A1628"/>
+        </a:solidFill>
+        <a:effectLst/>
+      </p:bgPr>
+    </p:bg>
+    <p:spTree>
+      <p:nvGrpSpPr>
+        <p:cNvPr id="1" name="">
+          <a:extLst>
+            <a:ext uri="{FF2B5EF4-FFF2-40B4-BE49-F238E27FC236}">
               <a16:creationId xmlns:a16="http://schemas.microsoft.com/office/drawing/2014/main" id="{06FA6B15-B6A1-153A-FE58-BADD20B6C303}"/>
             </a:ext>
           </a:extLst>
@@ -2472,7 +3058,7 @@
 </p:sld>
 </file>
 
-<file path=ppt/slides/slide6.xml><?xml version="1.0" encoding="utf-8"?>
+<file path=ppt/slides/slide7.xml><?xml version="1.0" encoding="utf-8"?>
 <p:sld xmlns:a="http://schemas.openxmlformats.org/drawingml/2006/main" xmlns:r="http://schemas.openxmlformats.org/officeDocument/2006/relationships" xmlns:p="http://schemas.openxmlformats.org/presentationml/2006/main">
   <p:cSld name="Slide 23">
     <p:bg>

</xml_diff>